<commit_message>
Update HLD/LLD/demo PPT with Front Door WebSocket fix
- HLD.docx: Section 6.1 notes the new CMD flags; Section 6.4 documents
  the Front Door WebSocket origin-mismatch issue and its resolution;
  new Section 9.6 covers the CORS/XSRF relaxation as a deliberate,
  documented security trade-off.
- LLD.docx: Section 9.1's Dockerfile table reflects the updated CMD;
  new Section 9.4 is a full diagnosis writeup (symptom, 4-step
  diagnosis via curl/WebSocket-test/Playwright/container-logs, root
  cause, the AFD-side fix attempted first and why it wasn't used, and
  the fix that shipped) -- preserved as reference material per the
  LLD's purpose (module/troubleshooting detail "for further
  reference").
- QuickLoan_Demo.pptx: added a bullet to the deployment slide.
</commit_message>
<xml_diff>
--- a/docs/QuickLoan_Demo.pptx
+++ b/docs/QuickLoan_Demo.pptx
@@ -3758,8 +3758,8 @@
         </p:nvSpPr>
         <p:spPr>
           <a:xfrm>
-            <a:off x="731520" y="1554480"/>
-            <a:ext cx="10698480" cy="4846320"/>
+            <a:off x="731520" y="1463040"/>
+            <a:ext cx="10698480" cy="5029200"/>
           </a:xfrm>
           <a:prstGeom prst="rect">
             <a:avLst/>
@@ -3774,11 +3774,11 @@
           <a:p>
             <a:pPr>
               <a:spcAft>
-                <a:spcPts val="1300"/>
+                <a:spcPts val="1100"/>
               </a:spcAft>
             </a:pPr>
             <a:r>
-              <a:rPr sz="1550" b="1">
+              <a:rPr sz="1400" b="1">
                 <a:solidFill>
                   <a:srgbClr val="1A365D"/>
                 </a:solidFill>
@@ -3786,7 +3786,7 @@
               <a:t>•  Docker multi-stage build  </a:t>
             </a:r>
             <a:r>
-              <a:rPr sz="1550">
+              <a:rPr sz="1400">
                 <a:solidFill>
                   <a:srgbClr val="2D3748"/>
                 </a:solidFill>
@@ -3797,11 +3797,11 @@
           <a:p>
             <a:pPr>
               <a:spcAft>
-                <a:spcPts val="1300"/>
+                <a:spcPts val="1100"/>
               </a:spcAft>
             </a:pPr>
             <a:r>
-              <a:rPr sz="1550" b="1">
+              <a:rPr sz="1400" b="1">
                 <a:solidFill>
                   <a:srgbClr val="1A365D"/>
                 </a:solidFill>
@@ -3809,7 +3809,7 @@
               <a:t>•  Data baked in at build time  </a:t>
             </a:r>
             <a:r>
-              <a:rPr sz="1550">
+              <a:rPr sz="1400">
                 <a:solidFill>
                   <a:srgbClr val="2D3748"/>
                 </a:solidFill>
@@ -3820,11 +3820,11 @@
           <a:p>
             <a:pPr>
               <a:spcAft>
-                <a:spcPts val="1300"/>
+                <a:spcPts val="1100"/>
               </a:spcAft>
             </a:pPr>
             <a:r>
-              <a:rPr sz="1550" b="1">
+              <a:rPr sz="1400" b="1">
                 <a:solidFill>
                   <a:srgbClr val="1A365D"/>
                 </a:solidFill>
@@ -3832,7 +3832,7 @@
               <a:t>•  Non-root, port 80  </a:t>
             </a:r>
             <a:r>
-              <a:rPr sz="1550">
+              <a:rPr sz="1400">
                 <a:solidFill>
                   <a:srgbClr val="2D3748"/>
                 </a:solidFill>
@@ -3843,11 +3843,11 @@
           <a:p>
             <a:pPr>
               <a:spcAft>
-                <a:spcPts val="1300"/>
+                <a:spcPts val="1100"/>
               </a:spcAft>
             </a:pPr>
             <a:r>
-              <a:rPr sz="1550" b="1">
+              <a:rPr sz="1400" b="1">
                 <a:solidFill>
                   <a:srgbClr val="1A365D"/>
                 </a:solidFill>
@@ -3855,7 +3855,7 @@
               <a:t>•  Azure Container Apps was blocked  </a:t>
             </a:r>
             <a:r>
-              <a:rPr sz="1550">
+              <a:rPr sz="1400">
                 <a:solidFill>
                   <a:srgbClr val="2D3748"/>
                 </a:solidFill>
@@ -3866,11 +3866,11 @@
           <a:p>
             <a:pPr>
               <a:spcAft>
-                <a:spcPts val="1300"/>
+                <a:spcPts val="1100"/>
               </a:spcAft>
             </a:pPr>
             <a:r>
-              <a:rPr sz="1550" b="1">
+              <a:rPr sz="1400" b="1">
                 <a:solidFill>
                   <a:srgbClr val="1A365D"/>
                 </a:solidFill>
@@ -3878,12 +3878,35 @@
               <a:t>•  Azure Front Door restores managed HTTPS  </a:t>
             </a:r>
             <a:r>
-              <a:rPr sz="1550">
+              <a:rPr sz="1400">
                 <a:solidFill>
                   <a:srgbClr val="2D3748"/>
                 </a:solidFill>
               </a:rPr>
               <a:t>ACI alone only serves plain HTTP; Front Door (Standard tier) adds a free managed TLS cert, HTTP→HTTPS redirect, and proxies to the ACI origin.</a:t>
+            </a:r>
+          </a:p>
+          <a:p>
+            <a:pPr>
+              <a:spcAft>
+                <a:spcPts val="1100"/>
+              </a:spcAft>
+            </a:pPr>
+            <a:r>
+              <a:rPr sz="1400" b="1">
+                <a:solidFill>
+                  <a:srgbClr val="1A365D"/>
+                </a:solidFill>
+              </a:rPr>
+              <a:t>•  WebSocket fix behind Front Door  </a:t>
+            </a:r>
+            <a:r>
+              <a:rPr sz="1400">
+                <a:solidFill>
+                  <a:srgbClr val="2D3748"/>
+                </a:solidFill>
+              </a:rPr>
+              <a:t>Streamlit rejected the UI's WebSocket (Origin ≠ Host through the proxy) — fixed via --server.enableCORS=false --server.enableXsrfProtection=false, verified live with Playwright.</a:t>
             </a:r>
           </a:p>
         </p:txBody>

</xml_diff>